<commit_message>
Anonymize example microscopy filenames
</commit_message>
<xml_diff>
--- a/examples/imaging/lsm/expected_output/data/lsm_qc_presentation.pptx
+++ b/examples/imaging/lsm/expected_output/data/lsm_qc_presentation.pptx
@@ -3104,7 +3104,7 @@
       <p:grpSpPr/>
       <p:pic>
         <p:nvPicPr>
-          <p:cNvPr id="2" name="Picture 1" descr="layout_del nt2 del cbd 1.png"/>
+          <p:cNvPr id="2" name="Picture 1" descr="layout_lsm_example_01.png"/>
           <p:cNvPicPr>
             <a:picLocks noChangeAspect="1"/>
           </p:cNvPicPr>
@@ -3156,7 +3156,7 @@
               </a:defRPr>
             </a:pPr>
             <a:r>
-              <a:t>LSM QC Review: del nt2 del cbd 1.png</a:t>
+              <a:t>LSM QC Review: lsm_example_01.png</a:t>
             </a:r>
           </a:p>
         </p:txBody>
@@ -3189,7 +3189,7 @@
       <p:grpSpPr/>
       <p:pic>
         <p:nvPicPr>
-          <p:cNvPr id="2" name="Picture 1" descr="layout_mkp5 sting.png"/>
+          <p:cNvPr id="2" name="Picture 1" descr="layout_lsm_example_02.png"/>
           <p:cNvPicPr>
             <a:picLocks noChangeAspect="1"/>
           </p:cNvPicPr>
@@ -3241,7 +3241,7 @@
               </a:defRPr>
             </a:pPr>
             <a:r>
-              <a:t>LSM QC Review: mkp5 sting.png</a:t>
+              <a:t>LSM QC Review: lsm_example_02.png</a:t>
             </a:r>
           </a:p>
         </p:txBody>
@@ -3274,7 +3274,7 @@
       <p:grpSpPr/>
       <p:pic>
         <p:nvPicPr>
-          <p:cNvPr id="2" name="Picture 1" descr="layout_mkp5 sting2.png"/>
+          <p:cNvPr id="2" name="Picture 1" descr="layout_lsm_example_03.png"/>
           <p:cNvPicPr>
             <a:picLocks noChangeAspect="1"/>
           </p:cNvPicPr>
@@ -3326,7 +3326,7 @@
               </a:defRPr>
             </a:pPr>
             <a:r>
-              <a:t>LSM QC Review: mkp5 sting2.png</a:t>
+              <a:t>LSM QC Review: lsm_example_03.png</a:t>
             </a:r>
           </a:p>
         </p:txBody>
@@ -3359,7 +3359,7 @@
       <p:grpSpPr/>
       <p:pic>
         <p:nvPicPr>
-          <p:cNvPr id="2" name="Picture 1" descr="layout_mkp5 sting3.png"/>
+          <p:cNvPr id="2" name="Picture 1" descr="layout_lsm_example_04.png"/>
           <p:cNvPicPr>
             <a:picLocks noChangeAspect="1"/>
           </p:cNvPicPr>
@@ -3411,7 +3411,7 @@
               </a:defRPr>
             </a:pPr>
             <a:r>
-              <a:t>LSM QC Review: mkp5 sting3.png</a:t>
+              <a:t>LSM QC Review: lsm_example_04.png</a:t>
             </a:r>
           </a:p>
         </p:txBody>
@@ -3444,7 +3444,7 @@
       <p:grpSpPr/>
       <p:pic>
         <p:nvPicPr>
-          <p:cNvPr id="2" name="Picture 1" descr="layout_mkp5 sting4.png"/>
+          <p:cNvPr id="2" name="Picture 1" descr="layout_lsm_example_05.png"/>
           <p:cNvPicPr>
             <a:picLocks noChangeAspect="1"/>
           </p:cNvPicPr>
@@ -3496,7 +3496,7 @@
               </a:defRPr>
             </a:pPr>
             <a:r>
-              <a:t>LSM QC Review: mkp5 sting4.png</a:t>
+              <a:t>LSM QC Review: lsm_example_05.png</a:t>
             </a:r>
           </a:p>
         </p:txBody>
@@ -3529,7 +3529,7 @@
       <p:grpSpPr/>
       <p:pic>
         <p:nvPicPr>
-          <p:cNvPr id="2" name="Picture 1" descr="layout_mkp5 sting5.png"/>
+          <p:cNvPr id="2" name="Picture 1" descr="layout_lsm_example_06.png"/>
           <p:cNvPicPr>
             <a:picLocks noChangeAspect="1"/>
           </p:cNvPicPr>
@@ -3581,7 +3581,7 @@
               </a:defRPr>
             </a:pPr>
             <a:r>
-              <a:t>LSM QC Review: mkp5 sting5.png</a:t>
+              <a:t>LSM QC Review: lsm_example_06.png</a:t>
             </a:r>
           </a:p>
         </p:txBody>
@@ -3614,7 +3614,7 @@
       <p:grpSpPr/>
       <p:pic>
         <p:nvPicPr>
-          <p:cNvPr id="2" name="Picture 1" descr="layout_mkp5 sting7.png"/>
+          <p:cNvPr id="2" name="Picture 1" descr="layout_lsm_example_08.png"/>
           <p:cNvPicPr>
             <a:picLocks noChangeAspect="1"/>
           </p:cNvPicPr>
@@ -3666,7 +3666,7 @@
               </a:defRPr>
             </a:pPr>
             <a:r>
-              <a:t>LSM QC Review: mkp5 sting7.png</a:t>
+              <a:t>LSM QC Review: lsm_example_08.png</a:t>
             </a:r>
           </a:p>
         </p:txBody>

</xml_diff>